<commit_message>
Se carga la presentacion de cloud
</commit_message>
<xml_diff>
--- a/Clases/Inyeccion de SQL, SPs, Funciones/Inyeccion SL, SPs, Funciones.pptx
+++ b/Clases/Inyeccion de SQL, SPs, Funciones/Inyeccion SL, SPs, Funciones.pptx
@@ -11347,14 +11347,21 @@
               <a:defRPr sz="1600"/>
             </a:pPr>
             <a:r>
-              <a:t>CREATE PROCEDURE sp_BuscarProducto</a:t>
-            </a:r>
+              <a:rPr dirty="0"/>
+              <a:t>CREATE PROCEDURE </a:t>
+            </a:r>
+            <a:r>
+              <a:rPr dirty="0" err="1"/>
+              <a:t>sp_BuscarProducto</a:t>
+            </a:r>
+            <a:endParaRPr dirty="0"/>
           </a:p>
           <a:p>
             <a:pPr>
               <a:defRPr sz="1600"/>
             </a:pPr>
             <a:r>
+              <a:rPr dirty="0"/>
               <a:t>   @nombre VARCHAR(100)</a:t>
             </a:r>
           </a:p>
@@ -11363,6 +11370,7 @@
               <a:defRPr sz="1600"/>
             </a:pPr>
             <a:r>
+              <a:rPr dirty="0"/>
               <a:t>AS</a:t>
             </a:r>
           </a:p>
@@ -11371,6 +11379,7 @@
               <a:defRPr sz="1600"/>
             </a:pPr>
             <a:r>
+              <a:rPr dirty="0"/>
               <a:t>BEGIN</a:t>
             </a:r>
           </a:p>
@@ -11379,6 +11388,7 @@
               <a:defRPr sz="1600"/>
             </a:pPr>
             <a:r>
+              <a:rPr dirty="0"/>
               <a:t>   SELECT *</a:t>
             </a:r>
           </a:p>
@@ -11387,6 +11397,7 @@
               <a:defRPr sz="1600"/>
             </a:pPr>
             <a:r>
+              <a:rPr dirty="0"/>
               <a:t>   FROM Productos</a:t>
             </a:r>
           </a:p>
@@ -11395,6 +11406,7 @@
               <a:defRPr sz="1600"/>
             </a:pPr>
             <a:r>
+              <a:rPr dirty="0"/>
               <a:t>   WHERE Nombre LIKE '%' + @nombre + '%'</a:t>
             </a:r>
           </a:p>
@@ -11403,6 +11415,7 @@
               <a:defRPr sz="1600"/>
             </a:pPr>
             <a:r>
+              <a:rPr dirty="0"/>
               <a:t>END</a:t>
             </a:r>
           </a:p>
@@ -12600,11 +12613,8 @@
               <a:defRPr sz="1600"/>
             </a:pPr>
             <a:r>
-              <a:t>DECLARE </a:t>
-            </a:r>
-            <a:r>
               <a:rPr dirty="0"/>
-              <a:t>@sql VARCHAR(MAX)</a:t>
+              <a:t>DECLARE @sql VARCHAR(MAX)</a:t>
             </a:r>
           </a:p>
           <a:p>

</xml_diff>